<commit_message>
Add placeholder markers to template title/subtitle text boxes
- Added Python script to fix template placeholders
- Removed warning text boxes from slide 1
- Added <p:ph type="ctrTitle"/> to title text boxes (slides 1-4)
- Added <p:ph type="subTitle"/> to subtitle text boxes (slides 1-4)
- This allows the PPTXMigrator to properly detect and replace title/subtitle content

https://claude.ai/code/session_01XzzhJCaFvuojRHHZUAyAXb
</commit_message>
<xml_diff>
--- a/template/Template_Transitionsphase_OESL_fixed.pptx
+++ b/template/Template_Transitionsphase_OESL_fixed.pptx
@@ -2458,6 +2458,7 @@
           </p:cNvPr>
           <p:cNvSpPr txBox="1"/>
           <p:nvPr>
+            <p:ph type="ctrTitle"/>
             <p:custDataLst>
               <p:tags r:id="rId1"/>
             </p:custDataLst>
@@ -2522,6 +2523,7 @@
           </p:cNvPr>
           <p:cNvSpPr txBox="1"/>
           <p:nvPr>
+            <p:ph type="subTitle"/>
             <p:custDataLst>
               <p:tags r:id="rId2"/>
             </p:custDataLst>
@@ -5512,6 +5514,7 @@
           </p:cNvPr>
           <p:cNvSpPr txBox="1"/>
           <p:nvPr>
+            <p:ph type="ctrTitle"/>
             <p:custDataLst>
               <p:tags r:id="rId1"/>
             </p:custDataLst>
@@ -5576,6 +5579,7 @@
           </p:cNvPr>
           <p:cNvSpPr txBox="1"/>
           <p:nvPr>
+            <p:ph type="subTitle"/>
             <p:custDataLst>
               <p:tags r:id="rId2"/>
             </p:custDataLst>
@@ -5775,7 +5779,9 @@
           <p:nvSpPr>
             <p:cNvPr id="3" name="TextBox 3"/>
             <p:cNvSpPr txBox="1"/>
-            <p:nvPr/>
+            <p:nvPr>
+              <p:ph type="subTitle"/>
+            </p:nvPr>
           </p:nvSpPr>
           <p:spPr>
             <a:xfrm>
@@ -5828,7 +5834,9 @@
           <p:nvSpPr>
             <p:cNvPr id="4" name="TextBox 4"/>
             <p:cNvSpPr txBox="1"/>
-            <p:nvPr/>
+            <p:nvPr>
+              <p:ph type="ctrTitle"/>
+            </p:nvPr>
           </p:nvSpPr>
           <p:spPr>
             <a:xfrm>
@@ -6147,7 +6155,9 @@
         <p:nvSpPr>
           <p:cNvPr id="2" name="TextBox 2"/>
           <p:cNvSpPr txBox="1"/>
-          <p:nvPr/>
+          <p:nvPr>
+            <p:ph type="ctrTitle"/>
+          </p:nvPr>
         </p:nvSpPr>
         <p:spPr>
           <a:xfrm>
@@ -6188,7 +6198,9 @@
         <p:nvSpPr>
           <p:cNvPr id="3" name="TextBox 3"/>
           <p:cNvSpPr txBox="1"/>
-          <p:nvPr/>
+          <p:nvPr>
+            <p:ph type="subTitle"/>
+          </p:nvPr>
         </p:nvSpPr>
         <p:spPr>
           <a:xfrm>

</xml_diff>

<commit_message>
Add body placeholder to slides 13 and 14
These are the most used template slides - added body placeholder
so the migrator can inject content into them.

- Slide 13: Added <p:ph type="body" idx="1"/>
- Slide 14: Added <p:ph type="body" idx="1"/>
- Updated fix script with add_body_placeholder function

https://claude.ai/code/session_01XzzhJCaFvuojRHHZUAyAXb
</commit_message>
<xml_diff>
--- a/template/Template_Transitionsphase_OESL_fixed.pptx
+++ b/template/Template_Transitionsphase_OESL_fixed.pptx
@@ -5009,6 +5009,33 @@
           </a:p>
         </p:txBody>
       </p:sp>
+      <p:sp>
+        <p:nvSpPr>
+          <p:cNvPr id="100" name="Content Placeholder 100"/>
+          <p:cNvSpPr>
+            <a:spLocks noGrp="1"/>
+          </p:cNvSpPr>
+          <p:nvPr>
+            <p:ph type="body" idx="1"/>
+          </p:nvPr>
+        </p:nvSpPr>
+        <p:spPr>
+          <a:xfrm>
+            <a:off x="457200" y="1200000"/>
+            <a:ext cx="17373600" cy="7800000"/>
+          </a:xfrm>
+          <a:prstGeom prst="rect">
+            <a:avLst/>
+          </a:prstGeom>
+        </p:spPr>
+        <p:txBody>
+          <a:bodyPr/>
+          <a:lstStyle/>
+          <a:p>
+            <a:endParaRPr lang="de-DE"/>
+          </a:p>
+        </p:txBody>
+      </p:sp>
     </p:spTree>
     <p:extLst>
       <p:ext uri="{BB962C8B-B14F-4D97-AF65-F5344CB8AC3E}">
@@ -5190,6 +5217,33 @@
           <a:solidFill>
             <a:srgbClr val="D9D9D9"/>
           </a:solidFill>
+        </p:spPr>
+        <p:txBody>
+          <a:bodyPr/>
+          <a:lstStyle/>
+          <a:p>
+            <a:endParaRPr lang="de-DE"/>
+          </a:p>
+        </p:txBody>
+      </p:sp>
+      <p:sp>
+        <p:nvSpPr>
+          <p:cNvPr id="100" name="Content Placeholder 100"/>
+          <p:cNvSpPr>
+            <a:spLocks noGrp="1"/>
+          </p:cNvSpPr>
+          <p:nvPr>
+            <p:ph type="body" idx="1"/>
+          </p:nvPr>
+        </p:nvSpPr>
+        <p:spPr>
+          <a:xfrm>
+            <a:off x="457200" y="1200000"/>
+            <a:ext cx="17373600" cy="7800000"/>
+          </a:xfrm>
+          <a:prstGeom prst="rect">
+            <a:avLst/>
+          </a:prstGeom>
         </p:spPr>
         <p:txBody>
           <a:bodyPr/>

</xml_diff>

<commit_message>
Add slide 15 two-column placeholders and create slide 16
Slide 15 (two-column layout):
- Added left body placeholder (idx=1)
- Added right body placeholder (idx=2)

Slide 16 (new - header/subheader/body layout):
- title placeholder (Header)
- subTitle placeholder (Subheader)
- body placeholder (Content area)
- Standard footer and slide number

Updated fix script with:
- add_two_column_body_placeholders() function
- create_slide_16() function to generate new slide with all required PPTX metadata

https://claude.ai/code/session_01XzzhJCaFvuojRHHZUAyAXb
</commit_message>
<xml_diff>
--- a/template/Template_Transitionsphase_OESL_fixed.pptx
+++ b/template/Template_Transitionsphase_OESL_fixed.pptx
@@ -23,6 +23,7 @@
     <p:sldId id="271" r:id="rId17"/>
     <p:sldId id="269" r:id="rId18"/>
     <p:sldId id="268" r:id="rId19"/>
+    <p:sldId id="273" r:id="rId28"/>
   </p:sldIdLst>
   <p:sldSz cx="18288000" cy="10287000"/>
   <p:notesSz cx="6858000" cy="9144000"/>
@@ -5486,12 +5487,214 @@
           </a:p>
         </p:txBody>
       </p:sp>
+      <p:sp>
+        <p:nvSpPr>
+          <p:cNvPr id="101" name="Content Placeholder Left"/>
+          <p:cNvSpPr>
+            <a:spLocks noGrp="1"/>
+          </p:cNvSpPr>
+          <p:nvPr>
+            <p:ph type="body" idx="1"/>
+          </p:nvPr>
+        </p:nvSpPr>
+        <p:spPr>
+          <a:xfrm>
+            <a:off x="457200" y="2000000"/>
+            <a:ext cx="8200000" cy="7000000"/>
+          </a:xfrm>
+          <a:prstGeom prst="rect">
+            <a:avLst/>
+          </a:prstGeom>
+        </p:spPr>
+        <p:txBody>
+          <a:bodyPr/>
+          <a:lstStyle/>
+          <a:p>
+            <a:endParaRPr lang="de-DE"/>
+          </a:p>
+        </p:txBody>
+      </p:sp>
+      <p:sp>
+        <p:nvSpPr>
+          <p:cNvPr id="102" name="Content Placeholder Right"/>
+          <p:cNvSpPr>
+            <a:spLocks noGrp="1"/>
+          </p:cNvSpPr>
+          <p:nvPr>
+            <p:ph type="body" idx="2"/>
+          </p:nvPr>
+        </p:nvSpPr>
+        <p:spPr>
+          <a:xfrm>
+            <a:off x="9600000" y="2000000"/>
+            <a:ext cx="8200000" cy="7000000"/>
+          </a:xfrm>
+          <a:prstGeom prst="rect">
+            <a:avLst/>
+          </a:prstGeom>
+        </p:spPr>
+        <p:txBody>
+          <a:bodyPr/>
+          <a:lstStyle/>
+          <a:p>
+            <a:endParaRPr lang="de-DE"/>
+          </a:p>
+        </p:txBody>
+      </p:sp>
     </p:spTree>
     <p:extLst>
       <p:ext uri="{BB962C8B-B14F-4D97-AF65-F5344CB8AC3E}">
         <p14:creationId xmlns:p14="http://schemas.microsoft.com/office/powerpoint/2010/main" val="1978295534"/>
       </p:ext>
     </p:extLst>
+  </p:cSld>
+  <p:clrMapOvr>
+    <a:masterClrMapping/>
+  </p:clrMapOvr>
+</p:sld>
+</file>
+
+<file path=ppt/slides/slide16.xml><?xml version="1.0" encoding="utf-8"?>
+<p:sld xmlns:a="http://schemas.openxmlformats.org/drawingml/2006/main" xmlns:r="http://schemas.openxmlformats.org/officeDocument/2006/relationships" xmlns:p="http://schemas.openxmlformats.org/presentationml/2006/main">
+  <p:cSld>
+    <p:spTree>
+      <p:nvGrpSpPr>
+        <p:cNvPr id="1" name=""/>
+        <p:cNvGrpSpPr/>
+        <p:nvPr/>
+      </p:nvGrpSpPr>
+      <p:grpSpPr>
+        <a:xfrm>
+          <a:off x="0" y="0"/>
+          <a:ext cx="0" cy="0"/>
+          <a:chOff x="0" y="0"/>
+          <a:chExt cx="0" cy="0"/>
+        </a:xfrm>
+      </p:grpSpPr>
+      <p:sp>
+        <p:nvSpPr>
+          <p:cNvPr id="2" name="Title 1"/>
+          <p:cNvSpPr>
+            <a:spLocks noGrp="1"/>
+          </p:cNvSpPr>
+          <p:nvPr>
+            <p:ph type="title"/>
+          </p:nvPr>
+        </p:nvSpPr>
+        <p:spPr>
+          <a:xfrm>
+            <a:off x="457200" y="274638"/>
+            <a:ext cx="17373600" cy="700000"/>
+          </a:xfrm>
+        </p:spPr>
+        <p:txBody>
+          <a:bodyPr/>
+          <a:lstStyle/>
+          <a:p>
+            <a:r>
+              <a:rPr lang="de-DE"/>
+              <a:t>Header</a:t>
+            </a:r>
+          </a:p>
+        </p:txBody>
+      </p:sp>
+      <p:sp>
+        <p:nvSpPr>
+          <p:cNvPr id="3" name="Subtitle 2"/>
+          <p:cNvSpPr>
+            <a:spLocks noGrp="1"/>
+          </p:cNvSpPr>
+          <p:nvPr>
+            <p:ph type="subTitle" idx="1"/>
+          </p:nvPr>
+        </p:nvSpPr>
+        <p:spPr>
+          <a:xfrm>
+            <a:off x="457200" y="1000000"/>
+            <a:ext cx="17373600" cy="500000"/>
+          </a:xfrm>
+        </p:spPr>
+        <p:txBody>
+          <a:bodyPr/>
+          <a:lstStyle/>
+          <a:p>
+            <a:r>
+              <a:rPr lang="de-DE"/>
+              <a:t>Subheader</a:t>
+            </a:r>
+          </a:p>
+        </p:txBody>
+      </p:sp>
+      <p:sp>
+        <p:nvSpPr>
+          <p:cNvPr id="4" name="Content 3"/>
+          <p:cNvSpPr>
+            <a:spLocks noGrp="1"/>
+          </p:cNvSpPr>
+          <p:nvPr>
+            <p:ph type="body" idx="2"/>
+          </p:nvPr>
+        </p:nvSpPr>
+        <p:spPr>
+          <a:xfrm>
+            <a:off x="457200" y="1600000"/>
+            <a:ext cx="17373600" cy="7400000"/>
+          </a:xfrm>
+        </p:spPr>
+        <p:txBody>
+          <a:bodyPr/>
+          <a:lstStyle/>
+          <a:p>
+            <a:endParaRPr lang="de-DE"/>
+          </a:p>
+        </p:txBody>
+      </p:sp>
+      <p:sp>
+        <p:nvSpPr>
+          <p:cNvPr id="5" name="Footer Placeholder 4"/>
+          <p:cNvSpPr>
+            <a:spLocks noGrp="1"/>
+          </p:cNvSpPr>
+          <p:nvPr>
+            <p:ph type="ftr" sz="quarter" idx="11"/>
+          </p:nvPr>
+        </p:nvSpPr>
+        <p:spPr/>
+        <p:txBody>
+          <a:bodyPr/>
+          <a:lstStyle/>
+          <a:p>
+            <a:r>
+              <a:rPr lang="de-DE"/>
+              <a:t>Original Equipment Solutions </a:t>
+            </a:r>
+          </a:p>
+        </p:txBody>
+      </p:sp>
+      <p:sp>
+        <p:nvSpPr>
+          <p:cNvPr id="6" name="Slide Number Placeholder 5"/>
+          <p:cNvSpPr>
+            <a:spLocks noGrp="1"/>
+          </p:cNvSpPr>
+          <p:nvPr>
+            <p:ph type="sldNum" sz="quarter" idx="12"/>
+          </p:nvPr>
+        </p:nvSpPr>
+        <p:spPr/>
+        <p:txBody>
+          <a:bodyPr/>
+          <a:lstStyle/>
+          <a:p>
+            <a:fld id="{DFC702AA-6566-462A-94F4-D9A629CE43FC}" type="slidenum">
+              <a:rPr lang="de-DE" smtClean="0"/>
+              <a:t>16</a:t>
+            </a:fld>
+            <a:endParaRPr lang="de-DE"/>
+          </a:p>
+        </p:txBody>
+      </p:sp>
+    </p:spTree>
   </p:cSld>
   <p:clrMapOvr>
     <a:masterClrMapping/>

</xml_diff>

<commit_message>
Fix template - disable slide 16 creation that caused corruption
Reverted to safe approach that only modifies existing slides:
- Slides 1-4: ctrTitle + subTitle placeholders
- Slides 13-14: title + body placeholders
- Slide 15: title + two-column body placeholders

Creating new slides requires more careful handling of PPTX metadata.

https://claude.ai/code/session_01XzzhJCaFvuojRHHZUAyAXb
</commit_message>
<xml_diff>
--- a/template/Template_Transitionsphase_OESL_fixed.pptx
+++ b/template/Template_Transitionsphase_OESL_fixed.pptx
@@ -23,7 +23,6 @@
     <p:sldId id="271" r:id="rId17"/>
     <p:sldId id="269" r:id="rId18"/>
     <p:sldId id="268" r:id="rId19"/>
-    <p:sldId id="273" r:id="rId28"/>
   </p:sldIdLst>
   <p:sldSz cx="18288000" cy="10287000"/>
   <p:notesSz cx="6858000" cy="9144000"/>
@@ -5547,154 +5546,6 @@
         <p14:creationId xmlns:p14="http://schemas.microsoft.com/office/powerpoint/2010/main" val="1978295534"/>
       </p:ext>
     </p:extLst>
-  </p:cSld>
-  <p:clrMapOvr>
-    <a:masterClrMapping/>
-  </p:clrMapOvr>
-</p:sld>
-</file>
-
-<file path=ppt/slides/slide16.xml><?xml version="1.0" encoding="utf-8"?>
-<p:sld xmlns:a="http://schemas.openxmlformats.org/drawingml/2006/main" xmlns:r="http://schemas.openxmlformats.org/officeDocument/2006/relationships" xmlns:p="http://schemas.openxmlformats.org/presentationml/2006/main">
-  <p:cSld>
-    <p:spTree>
-      <p:nvGrpSpPr>
-        <p:cNvPr id="1" name=""/>
-        <p:cNvGrpSpPr/>
-        <p:nvPr/>
-      </p:nvGrpSpPr>
-      <p:grpSpPr>
-        <a:xfrm>
-          <a:off x="0" y="0"/>
-          <a:ext cx="0" cy="0"/>
-          <a:chOff x="0" y="0"/>
-          <a:chExt cx="0" cy="0"/>
-        </a:xfrm>
-      </p:grpSpPr>
-      <p:sp>
-        <p:nvSpPr>
-          <p:cNvPr id="2" name="Title 1"/>
-          <p:cNvSpPr>
-            <a:spLocks noGrp="1"/>
-          </p:cNvSpPr>
-          <p:nvPr>
-            <p:ph type="title"/>
-          </p:nvPr>
-        </p:nvSpPr>
-        <p:spPr>
-          <a:xfrm>
-            <a:off x="457200" y="274638"/>
-            <a:ext cx="17373600" cy="700000"/>
-          </a:xfrm>
-        </p:spPr>
-        <p:txBody>
-          <a:bodyPr/>
-          <a:lstStyle/>
-          <a:p>
-            <a:r>
-              <a:rPr lang="de-DE"/>
-              <a:t>Header</a:t>
-            </a:r>
-          </a:p>
-        </p:txBody>
-      </p:sp>
-      <p:sp>
-        <p:nvSpPr>
-          <p:cNvPr id="3" name="Subtitle 2"/>
-          <p:cNvSpPr>
-            <a:spLocks noGrp="1"/>
-          </p:cNvSpPr>
-          <p:nvPr>
-            <p:ph type="subTitle" idx="1"/>
-          </p:nvPr>
-        </p:nvSpPr>
-        <p:spPr>
-          <a:xfrm>
-            <a:off x="457200" y="1000000"/>
-            <a:ext cx="17373600" cy="500000"/>
-          </a:xfrm>
-        </p:spPr>
-        <p:txBody>
-          <a:bodyPr/>
-          <a:lstStyle/>
-          <a:p>
-            <a:r>
-              <a:rPr lang="de-DE"/>
-              <a:t>Subheader</a:t>
-            </a:r>
-          </a:p>
-        </p:txBody>
-      </p:sp>
-      <p:sp>
-        <p:nvSpPr>
-          <p:cNvPr id="4" name="Content 3"/>
-          <p:cNvSpPr>
-            <a:spLocks noGrp="1"/>
-          </p:cNvSpPr>
-          <p:nvPr>
-            <p:ph type="body" idx="2"/>
-          </p:nvPr>
-        </p:nvSpPr>
-        <p:spPr>
-          <a:xfrm>
-            <a:off x="457200" y="1600000"/>
-            <a:ext cx="17373600" cy="7400000"/>
-          </a:xfrm>
-        </p:spPr>
-        <p:txBody>
-          <a:bodyPr/>
-          <a:lstStyle/>
-          <a:p>
-            <a:endParaRPr lang="de-DE"/>
-          </a:p>
-        </p:txBody>
-      </p:sp>
-      <p:sp>
-        <p:nvSpPr>
-          <p:cNvPr id="5" name="Footer Placeholder 4"/>
-          <p:cNvSpPr>
-            <a:spLocks noGrp="1"/>
-          </p:cNvSpPr>
-          <p:nvPr>
-            <p:ph type="ftr" sz="quarter" idx="11"/>
-          </p:nvPr>
-        </p:nvSpPr>
-        <p:spPr/>
-        <p:txBody>
-          <a:bodyPr/>
-          <a:lstStyle/>
-          <a:p>
-            <a:r>
-              <a:rPr lang="de-DE"/>
-              <a:t>Original Equipment Solutions </a:t>
-            </a:r>
-          </a:p>
-        </p:txBody>
-      </p:sp>
-      <p:sp>
-        <p:nvSpPr>
-          <p:cNvPr id="6" name="Slide Number Placeholder 5"/>
-          <p:cNvSpPr>
-            <a:spLocks noGrp="1"/>
-          </p:cNvSpPr>
-          <p:nvPr>
-            <p:ph type="sldNum" sz="quarter" idx="12"/>
-          </p:nvPr>
-        </p:nvSpPr>
-        <p:spPr/>
-        <p:txBody>
-          <a:bodyPr/>
-          <a:lstStyle/>
-          <a:p>
-            <a:fld id="{DFC702AA-6566-462A-94F4-D9A629CE43FC}" type="slidenum">
-              <a:rPr lang="de-DE" smtClean="0"/>
-              <a:t>16</a:t>
-            </a:fld>
-            <a:endParaRPr lang="de-DE"/>
-          </a:p>
-        </p:txBody>
-      </p:sp>
-    </p:spTree>
   </p:cSld>
   <p:clrMapOvr>
     <a:masterClrMapping/>

</xml_diff>

<commit_message>
Minimal template fix - only slides 1-4 placeholders
Disabled body placeholder additions that may cause corruption.
Only changes:
- Remove warning boxes from slide 1
- Add ctrTitle/subTitle to slides 1-4 text boxes

https://claude.ai/code/session_01XzzhJCaFvuojRHHZUAyAXb
</commit_message>
<xml_diff>
--- a/template/Template_Transitionsphase_OESL_fixed.pptx
+++ b/template/Template_Transitionsphase_OESL_fixed.pptx
@@ -5009,33 +5009,6 @@
           </a:p>
         </p:txBody>
       </p:sp>
-      <p:sp>
-        <p:nvSpPr>
-          <p:cNvPr id="100" name="Content Placeholder 100"/>
-          <p:cNvSpPr>
-            <a:spLocks noGrp="1"/>
-          </p:cNvSpPr>
-          <p:nvPr>
-            <p:ph type="body" idx="1"/>
-          </p:nvPr>
-        </p:nvSpPr>
-        <p:spPr>
-          <a:xfrm>
-            <a:off x="457200" y="1200000"/>
-            <a:ext cx="17373600" cy="7800000"/>
-          </a:xfrm>
-          <a:prstGeom prst="rect">
-            <a:avLst/>
-          </a:prstGeom>
-        </p:spPr>
-        <p:txBody>
-          <a:bodyPr/>
-          <a:lstStyle/>
-          <a:p>
-            <a:endParaRPr lang="de-DE"/>
-          </a:p>
-        </p:txBody>
-      </p:sp>
     </p:spTree>
     <p:extLst>
       <p:ext uri="{BB962C8B-B14F-4D97-AF65-F5344CB8AC3E}">
@@ -5226,33 +5199,6 @@
           </a:p>
         </p:txBody>
       </p:sp>
-      <p:sp>
-        <p:nvSpPr>
-          <p:cNvPr id="100" name="Content Placeholder 100"/>
-          <p:cNvSpPr>
-            <a:spLocks noGrp="1"/>
-          </p:cNvSpPr>
-          <p:nvPr>
-            <p:ph type="body" idx="1"/>
-          </p:nvPr>
-        </p:nvSpPr>
-        <p:spPr>
-          <a:xfrm>
-            <a:off x="457200" y="1200000"/>
-            <a:ext cx="17373600" cy="7800000"/>
-          </a:xfrm>
-          <a:prstGeom prst="rect">
-            <a:avLst/>
-          </a:prstGeom>
-        </p:spPr>
-        <p:txBody>
-          <a:bodyPr/>
-          <a:lstStyle/>
-          <a:p>
-            <a:endParaRPr lang="de-DE"/>
-          </a:p>
-        </p:txBody>
-      </p:sp>
     </p:spTree>
     <p:extLst>
       <p:ext uri="{BB962C8B-B14F-4D97-AF65-F5344CB8AC3E}">
@@ -5477,60 +5423,6 @@
           <a:solidFill>
             <a:srgbClr val="D9D9D9"/>
           </a:solidFill>
-        </p:spPr>
-        <p:txBody>
-          <a:bodyPr/>
-          <a:lstStyle/>
-          <a:p>
-            <a:endParaRPr lang="de-DE"/>
-          </a:p>
-        </p:txBody>
-      </p:sp>
-      <p:sp>
-        <p:nvSpPr>
-          <p:cNvPr id="101" name="Content Placeholder Left"/>
-          <p:cNvSpPr>
-            <a:spLocks noGrp="1"/>
-          </p:cNvSpPr>
-          <p:nvPr>
-            <p:ph type="body" idx="1"/>
-          </p:nvPr>
-        </p:nvSpPr>
-        <p:spPr>
-          <a:xfrm>
-            <a:off x="457200" y="2000000"/>
-            <a:ext cx="8200000" cy="7000000"/>
-          </a:xfrm>
-          <a:prstGeom prst="rect">
-            <a:avLst/>
-          </a:prstGeom>
-        </p:spPr>
-        <p:txBody>
-          <a:bodyPr/>
-          <a:lstStyle/>
-          <a:p>
-            <a:endParaRPr lang="de-DE"/>
-          </a:p>
-        </p:txBody>
-      </p:sp>
-      <p:sp>
-        <p:nvSpPr>
-          <p:cNvPr id="102" name="Content Placeholder Right"/>
-          <p:cNvSpPr>
-            <a:spLocks noGrp="1"/>
-          </p:cNvSpPr>
-          <p:nvPr>
-            <p:ph type="body" idx="2"/>
-          </p:nvPr>
-        </p:nvSpPr>
-        <p:spPr>
-          <a:xfrm>
-            <a:off x="9600000" y="2000000"/>
-            <a:ext cx="8200000" cy="7000000"/>
-          </a:xfrm>
-          <a:prstGeom prst="rect">
-            <a:avLst/>
-          </a:prstGeom>
         </p:spPr>
         <p:txBody>
           <a:bodyPr/>

</xml_diff>

<commit_message>
Test: Only remove warning boxes, no placeholder changes
Disabled all placeholder additions to isolate the issue.
Only change: remove warning text boxes from slide 1.

https://claude.ai/code/session_01XzzhJCaFvuojRHHZUAyAXb
</commit_message>
<xml_diff>
--- a/template/Template_Transitionsphase_OESL_fixed.pptx
+++ b/template/Template_Transitionsphase_OESL_fixed.pptx
@@ -2458,7 +2458,6 @@
           </p:cNvPr>
           <p:cNvSpPr txBox="1"/>
           <p:nvPr>
-            <p:ph type="ctrTitle"/>
             <p:custDataLst>
               <p:tags r:id="rId1"/>
             </p:custDataLst>
@@ -2523,7 +2522,6 @@
           </p:cNvPr>
           <p:cNvSpPr txBox="1"/>
           <p:nvPr>
-            <p:ph type="subTitle"/>
             <p:custDataLst>
               <p:tags r:id="rId2"/>
             </p:custDataLst>
@@ -5514,7 +5512,6 @@
           </p:cNvPr>
           <p:cNvSpPr txBox="1"/>
           <p:nvPr>
-            <p:ph type="ctrTitle"/>
             <p:custDataLst>
               <p:tags r:id="rId1"/>
             </p:custDataLst>
@@ -5579,7 +5576,6 @@
           </p:cNvPr>
           <p:cNvSpPr txBox="1"/>
           <p:nvPr>
-            <p:ph type="subTitle"/>
             <p:custDataLst>
               <p:tags r:id="rId2"/>
             </p:custDataLst>
@@ -5779,9 +5775,7 @@
           <p:nvSpPr>
             <p:cNvPr id="3" name="TextBox 3"/>
             <p:cNvSpPr txBox="1"/>
-            <p:nvPr>
-              <p:ph type="subTitle"/>
-            </p:nvPr>
+            <p:nvPr/>
           </p:nvSpPr>
           <p:spPr>
             <a:xfrm>
@@ -5834,9 +5828,7 @@
           <p:nvSpPr>
             <p:cNvPr id="4" name="TextBox 4"/>
             <p:cNvSpPr txBox="1"/>
-            <p:nvPr>
-              <p:ph type="ctrTitle"/>
-            </p:nvPr>
+            <p:nvPr/>
           </p:nvSpPr>
           <p:spPr>
             <a:xfrm>
@@ -6155,9 +6147,7 @@
         <p:nvSpPr>
           <p:cNvPr id="2" name="TextBox 2"/>
           <p:cNvSpPr txBox="1"/>
-          <p:nvPr>
-            <p:ph type="ctrTitle"/>
-          </p:nvPr>
+          <p:nvPr/>
         </p:nvSpPr>
         <p:spPr>
           <a:xfrm>
@@ -6198,9 +6188,7 @@
         <p:nvSpPr>
           <p:cNvPr id="3" name="TextBox 3"/>
           <p:cNvSpPr txBox="1"/>
-          <p:nvPr>
-            <p:ph type="subTitle"/>
-          </p:nvPr>
+          <p:nvPr/>
         </p:nvSpPr>
         <p:spPr>
           <a:xfrm>

</xml_diff>